<commit_message>
Add Ctrl+Shift+4 scrolling capture
Co-authored-by: Copilot App <223556219+Copilot@users.noreply.github.com>
</commit_message>
<xml_diff>
--- a/ShareX mini training.pptx
+++ b/ShareX mini training.pptx
@@ -108,12 +108,12 @@
   <p:extLst>
     <p:ext uri="{521415D9-36F7-43E2-AB2F-B90AF26B5E84}">
       <p14:sectionLst xmlns:p14="http://schemas.microsoft.com/office/powerpoint/2010/main">
-        <p14:section name="Shortcuts" id="{58180996-7336-8764-A680-201D76FEAF2D}">
+        <p14:section name="Shortcuts" id="{C4E14D8D-622B-1CE6-1D8B-9DFDC4E09D47}">
           <p14:sldIdLst>
             <p14:sldId id="256"/>
           </p14:sldIdLst>
         </p14:section>
-        <p14:section name="Try it" id="{3984F790-BF81-9FA4-A1AC-4490F13AD3C9}">
+        <p14:section name="Try it" id="{4F949A32-8E19-D33E-621C-342B941E91D8}">
           <p14:sldIdLst>
             <p14:sldId id="257"/>
           </p14:sldIdLst>
@@ -152,7 +152,7 @@
     </p:spTree>
     <p:extLst>
       <p:ext uri="{BB962C8B-B14F-4D97-AF65-F5344CB8AC3E}">
-        <p14:creationId xmlns:p14="http://schemas.microsoft.com/office/powerpoint/2010/main" val="982492418"/>
+        <p14:creationId xmlns:p14="http://schemas.microsoft.com/office/powerpoint/2010/main" val="1436382890"/>
       </p:ext>
     </p:extLst>
   </p:cSld>
@@ -298,7 +298,7 @@
           <a:p>
             <a:r>
               <a:rPr lang="en-US" dirty="0"/>
-              <a:t>Ctrl+Shift+1: frame chooser. Ctrl+Shift+2: default grey rounded border. Ctrl+Shift+3: straight to the clipboard, ideal for pasting into AI when you want speed and no frame.</a:t>
+              <a:t>Ctrl+Shift+1: frame chooser. Ctrl+Shift+2: default grey rounded border. Ctrl+Shift+3: straight to the clipboard, ideal for pasting into AI when you want speed. Ctrl+Shift+4: scrolling capture, click the window and ShareX scrolls and stitches one long image.</a:t>
             </a:r>
           </a:p>
         </p:txBody>
@@ -385,7 +385,7 @@
           <a:p>
             <a:r>
               <a:rPr lang="en-US" dirty="0"/>
-              <a:t>The prompt backs up existing ShareX settings first and installs ShareX only when it is missing. It changes only the three region hotkeys, the frames, sound and the exit confirmation.</a:t>
+              <a:t>The prompt backs up existing ShareX settings first and installs ShareX only when it is missing. It changes only the four hotkeys, the frames, sound and the exit confirmation.</a:t>
             </a:r>
           </a:p>
         </p:txBody>
@@ -1193,7 +1193,7 @@
                 <a:ea typeface="SkylineSans Black" pitchFamily="34" charset="-122"/>
                 <a:cs typeface="SkylineSans Black" pitchFamily="34" charset="-120"/>
               </a:rPr>
-              <a:t>three shortcuts</a:t>
+              <a:t>four shortcuts</a:t>
             </a:r>
             <a:endParaRPr lang="en-US" sz="3400" dirty="0"/>
           </a:p>
@@ -1232,11 +1232,11 @@
         <p:spPr>
           <a:xfrm>
             <a:off x="1038734" y="1965960"/>
-            <a:ext cx="3205213" cy="3383280"/>
+            <a:ext cx="2368296" cy="3383280"/>
           </a:xfrm>
           <a:prstGeom prst="roundRect">
             <a:avLst>
-              <a:gd name="adj" fmla="val 3423"/>
+              <a:gd name="adj" fmla="val 4633"/>
             </a:avLst>
           </a:prstGeom>
           <a:gradFill rotWithShape="1">
@@ -1266,12 +1266,12 @@
         </p:nvSpPr>
         <p:spPr>
           <a:xfrm>
-            <a:off x="1252415" y="2215254"/>
-            <a:ext cx="854723" cy="641043"/>
+            <a:off x="1216802" y="2215254"/>
+            <a:ext cx="641043" cy="534202"/>
           </a:xfrm>
           <a:prstGeom prst="roundRect">
             <a:avLst>
-              <a:gd name="adj" fmla="val 17117"/>
+              <a:gd name="adj" fmla="val 20541"/>
             </a:avLst>
           </a:prstGeom>
           <a:gradFill rotWithShape="1">
@@ -1301,12 +1301,12 @@
         </p:nvSpPr>
         <p:spPr>
           <a:xfrm>
-            <a:off x="2196172" y="2215254"/>
-            <a:ext cx="997177" cy="641043"/>
+            <a:off x="1929071" y="2215254"/>
+            <a:ext cx="765690" cy="534202"/>
           </a:xfrm>
           <a:prstGeom prst="roundRect">
             <a:avLst>
-              <a:gd name="adj" fmla="val 17117"/>
+              <a:gd name="adj" fmla="val 20541"/>
             </a:avLst>
           </a:prstGeom>
           <a:gradFill rotWithShape="1">
@@ -1336,12 +1336,12 @@
         </p:nvSpPr>
         <p:spPr>
           <a:xfrm>
-            <a:off x="3282383" y="2215254"/>
-            <a:ext cx="641043" cy="641043"/>
+            <a:off x="2765988" y="2215254"/>
+            <a:ext cx="462975" cy="534202"/>
           </a:xfrm>
           <a:prstGeom prst="roundRect">
             <a:avLst>
-              <a:gd name="adj" fmla="val 17117"/>
+              <a:gd name="adj" fmla="val 23701"/>
             </a:avLst>
           </a:prstGeom>
           <a:gradFill rotWithShape="1">
@@ -1371,7 +1371,7 @@
         </p:nvSpPr>
         <p:spPr>
           <a:xfrm>
-            <a:off x="1252415" y="4779424"/>
+            <a:off x="1216802" y="4779424"/>
             <a:ext cx="558825" cy="231488"/>
           </a:xfrm>
           <a:prstGeom prst="roundRect">
@@ -1400,7 +1400,7 @@
         </p:nvSpPr>
         <p:spPr>
           <a:xfrm>
-            <a:off x="1873564" y="4779424"/>
+            <a:off x="1837951" y="4779424"/>
             <a:ext cx="727989" cy="231488"/>
           </a:xfrm>
           <a:prstGeom prst="roundRect">
@@ -1429,12 +1429,12 @@
         </p:nvSpPr>
         <p:spPr>
           <a:xfrm>
-            <a:off x="4493241" y="1965960"/>
-            <a:ext cx="3205213" cy="3383280"/>
+            <a:off x="3620711" y="1965960"/>
+            <a:ext cx="2368296" cy="3383280"/>
           </a:xfrm>
           <a:prstGeom prst="roundRect">
             <a:avLst>
-              <a:gd name="adj" fmla="val 3423"/>
+              <a:gd name="adj" fmla="val 4633"/>
             </a:avLst>
           </a:prstGeom>
           <a:gradFill rotWithShape="1">
@@ -1464,12 +1464,12 @@
         </p:nvSpPr>
         <p:spPr>
           <a:xfrm>
-            <a:off x="4706922" y="2215254"/>
-            <a:ext cx="854723" cy="641043"/>
+            <a:off x="3798779" y="2215254"/>
+            <a:ext cx="641043" cy="534202"/>
           </a:xfrm>
           <a:prstGeom prst="roundRect">
             <a:avLst>
-              <a:gd name="adj" fmla="val 17117"/>
+              <a:gd name="adj" fmla="val 20541"/>
             </a:avLst>
           </a:prstGeom>
           <a:gradFill rotWithShape="1">
@@ -1499,12 +1499,12 @@
         </p:nvSpPr>
         <p:spPr>
           <a:xfrm>
-            <a:off x="5650679" y="2215254"/>
-            <a:ext cx="997177" cy="641043"/>
+            <a:off x="4511048" y="2215254"/>
+            <a:ext cx="765690" cy="534202"/>
           </a:xfrm>
           <a:prstGeom prst="roundRect">
             <a:avLst>
-              <a:gd name="adj" fmla="val 17117"/>
+              <a:gd name="adj" fmla="val 20541"/>
             </a:avLst>
           </a:prstGeom>
           <a:gradFill rotWithShape="1">
@@ -1534,12 +1534,12 @@
         </p:nvSpPr>
         <p:spPr>
           <a:xfrm>
-            <a:off x="6736890" y="2215254"/>
-            <a:ext cx="641043" cy="641043"/>
+            <a:off x="5347965" y="2215254"/>
+            <a:ext cx="462975" cy="534202"/>
           </a:xfrm>
           <a:prstGeom prst="roundRect">
             <a:avLst>
-              <a:gd name="adj" fmla="val 17117"/>
+              <a:gd name="adj" fmla="val 23701"/>
             </a:avLst>
           </a:prstGeom>
           <a:gradFill rotWithShape="1">
@@ -1569,8 +1569,8 @@
         </p:nvSpPr>
         <p:spPr>
           <a:xfrm>
-            <a:off x="4706922" y="4779424"/>
-            <a:ext cx="887972" cy="231488"/>
+            <a:off x="3798779" y="4779424"/>
+            <a:ext cx="587205" cy="231488"/>
           </a:xfrm>
           <a:prstGeom prst="roundRect">
             <a:avLst>
@@ -1598,7 +1598,7 @@
         </p:nvSpPr>
         <p:spPr>
           <a:xfrm>
-            <a:off x="5657218" y="4779424"/>
+            <a:off x="4448307" y="4779424"/>
             <a:ext cx="727989" cy="231488"/>
           </a:xfrm>
           <a:prstGeom prst="roundRect">
@@ -1627,12 +1627,12 @@
         </p:nvSpPr>
         <p:spPr>
           <a:xfrm>
-            <a:off x="7947748" y="1965960"/>
-            <a:ext cx="3205213" cy="3383280"/>
+            <a:off x="6202688" y="1965960"/>
+            <a:ext cx="2368296" cy="3383280"/>
           </a:xfrm>
           <a:prstGeom prst="roundRect">
             <a:avLst>
-              <a:gd name="adj" fmla="val 3423"/>
+              <a:gd name="adj" fmla="val 4633"/>
             </a:avLst>
           </a:prstGeom>
           <a:gradFill rotWithShape="1">
@@ -1669,12 +1669,12 @@
         </p:nvSpPr>
         <p:spPr>
           <a:xfrm>
-            <a:off x="8161429" y="2215254"/>
-            <a:ext cx="854723" cy="641043"/>
+            <a:off x="6380755" y="2215254"/>
+            <a:ext cx="641043" cy="534202"/>
           </a:xfrm>
           <a:prstGeom prst="roundRect">
             <a:avLst>
-              <a:gd name="adj" fmla="val 17117"/>
+              <a:gd name="adj" fmla="val 20541"/>
             </a:avLst>
           </a:prstGeom>
           <a:gradFill rotWithShape="1">
@@ -1704,12 +1704,12 @@
         </p:nvSpPr>
         <p:spPr>
           <a:xfrm>
-            <a:off x="9105186" y="2215254"/>
-            <a:ext cx="997177" cy="641043"/>
+            <a:off x="7093025" y="2215254"/>
+            <a:ext cx="765690" cy="534202"/>
           </a:xfrm>
           <a:prstGeom prst="roundRect">
             <a:avLst>
-              <a:gd name="adj" fmla="val 17117"/>
+              <a:gd name="adj" fmla="val 20541"/>
             </a:avLst>
           </a:prstGeom>
           <a:gradFill rotWithShape="1">
@@ -1739,12 +1739,12 @@
         </p:nvSpPr>
         <p:spPr>
           <a:xfrm>
-            <a:off x="10191397" y="2215254"/>
-            <a:ext cx="641043" cy="641043"/>
+            <a:off x="7929941" y="2215254"/>
+            <a:ext cx="462975" cy="534202"/>
           </a:xfrm>
           <a:prstGeom prst="roundRect">
             <a:avLst>
-              <a:gd name="adj" fmla="val 17117"/>
+              <a:gd name="adj" fmla="val 23701"/>
             </a:avLst>
           </a:prstGeom>
           <a:gradFill rotWithShape="1">
@@ -1774,8 +1774,8 @@
         </p:nvSpPr>
         <p:spPr>
           <a:xfrm>
-            <a:off x="8161429" y="4779424"/>
-            <a:ext cx="887972" cy="231488"/>
+            <a:off x="6380755" y="4779424"/>
+            <a:ext cx="587205" cy="231488"/>
           </a:xfrm>
           <a:prstGeom prst="roundRect">
             <a:avLst>
@@ -1816,7 +1816,7 @@
         </p:nvSpPr>
         <p:spPr>
           <a:xfrm>
-            <a:off x="9111725" y="4779424"/>
+            <a:off x="7030284" y="4779424"/>
             <a:ext cx="760960" cy="231488"/>
           </a:xfrm>
           <a:prstGeom prst="roundRect">
@@ -1852,14 +1852,212 @@
       </p:sp>
       <p:sp>
         <p:nvSpPr>
-          <p:cNvPr id="24" name="Text:schema"/>
-          <p:cNvSpPr/>
-          <p:nvPr/>
-        </p:nvSpPr>
-        <p:spPr>
-          <a:xfrm>
-            <a:off x="1487381" y="2406677"/>
-            <a:ext cx="384653" cy="276004"/>
+          <p:cNvPr id="24" name="Schema"/>
+          <p:cNvSpPr/>
+          <p:nvPr/>
+        </p:nvSpPr>
+        <p:spPr>
+          <a:xfrm>
+            <a:off x="8784665" y="1965960"/>
+            <a:ext cx="2368296" cy="3383280"/>
+          </a:xfrm>
+          <a:prstGeom prst="roundRect">
+            <a:avLst>
+              <a:gd name="adj" fmla="val 4633"/>
+            </a:avLst>
+          </a:prstGeom>
+          <a:gradFill rotWithShape="1">
+            <a:gsLst>
+              <a:gs pos="0">
+                <a:srgbClr val="111827"/>
+              </a:gs>
+              <a:gs pos="100000">
+                <a:srgbClr val="0B1120"/>
+              </a:gs>
+            </a:gsLst>
+            <a:lin ang="5400000" scaled="0"/>
+          </a:gradFill>
+          <a:ln w="8903">
+            <a:solidFill>
+              <a:srgbClr val="1F2937"/>
+            </a:solidFill>
+            <a:prstDash val="solid"/>
+          </a:ln>
+        </p:spPr>
+      </p:sp>
+      <p:sp>
+        <p:nvSpPr>
+          <p:cNvPr id="25" name="Schema"/>
+          <p:cNvSpPr/>
+          <p:nvPr/>
+        </p:nvSpPr>
+        <p:spPr>
+          <a:xfrm>
+            <a:off x="8962732" y="2215254"/>
+            <a:ext cx="641043" cy="534202"/>
+          </a:xfrm>
+          <a:prstGeom prst="roundRect">
+            <a:avLst>
+              <a:gd name="adj" fmla="val 20541"/>
+            </a:avLst>
+          </a:prstGeom>
+          <a:gradFill rotWithShape="1">
+            <a:gsLst>
+              <a:gs pos="0">
+                <a:srgbClr val="111827"/>
+              </a:gs>
+              <a:gs pos="100000">
+                <a:srgbClr val="0B1120"/>
+              </a:gs>
+            </a:gsLst>
+            <a:lin ang="5400000" scaled="0"/>
+          </a:gradFill>
+          <a:ln w="8903">
+            <a:solidFill>
+              <a:srgbClr val="1F2937"/>
+            </a:solidFill>
+            <a:prstDash val="solid"/>
+          </a:ln>
+        </p:spPr>
+      </p:sp>
+      <p:sp>
+        <p:nvSpPr>
+          <p:cNvPr id="26" name="Schema"/>
+          <p:cNvSpPr/>
+          <p:nvPr/>
+        </p:nvSpPr>
+        <p:spPr>
+          <a:xfrm>
+            <a:off x="9675002" y="2215254"/>
+            <a:ext cx="765690" cy="534202"/>
+          </a:xfrm>
+          <a:prstGeom prst="roundRect">
+            <a:avLst>
+              <a:gd name="adj" fmla="val 20541"/>
+            </a:avLst>
+          </a:prstGeom>
+          <a:gradFill rotWithShape="1">
+            <a:gsLst>
+              <a:gs pos="0">
+                <a:srgbClr val="111827"/>
+              </a:gs>
+              <a:gs pos="100000">
+                <a:srgbClr val="0B1120"/>
+              </a:gs>
+            </a:gsLst>
+            <a:lin ang="5400000" scaled="0"/>
+          </a:gradFill>
+          <a:ln w="8903">
+            <a:solidFill>
+              <a:srgbClr val="1F2937"/>
+            </a:solidFill>
+            <a:prstDash val="solid"/>
+          </a:ln>
+        </p:spPr>
+      </p:sp>
+      <p:sp>
+        <p:nvSpPr>
+          <p:cNvPr id="27" name="Schema"/>
+          <p:cNvSpPr/>
+          <p:nvPr/>
+        </p:nvSpPr>
+        <p:spPr>
+          <a:xfrm>
+            <a:off x="10511918" y="2215254"/>
+            <a:ext cx="462975" cy="534202"/>
+          </a:xfrm>
+          <a:prstGeom prst="roundRect">
+            <a:avLst>
+              <a:gd name="adj" fmla="val 23701"/>
+            </a:avLst>
+          </a:prstGeom>
+          <a:gradFill rotWithShape="1">
+            <a:gsLst>
+              <a:gs pos="0">
+                <a:srgbClr val="111827"/>
+              </a:gs>
+              <a:gs pos="100000">
+                <a:srgbClr val="0B1120"/>
+              </a:gs>
+            </a:gsLst>
+            <a:lin ang="5400000" scaled="0"/>
+          </a:gradFill>
+          <a:ln w="8903">
+            <a:solidFill>
+              <a:srgbClr val="1F2937"/>
+            </a:solidFill>
+            <a:prstDash val="solid"/>
+          </a:ln>
+        </p:spPr>
+      </p:sp>
+      <p:sp>
+        <p:nvSpPr>
+          <p:cNvPr id="28" name="Schema"/>
+          <p:cNvSpPr/>
+          <p:nvPr/>
+        </p:nvSpPr>
+        <p:spPr>
+          <a:xfrm>
+            <a:off x="8962732" y="4779424"/>
+            <a:ext cx="525299" cy="231488"/>
+          </a:xfrm>
+          <a:prstGeom prst="roundRect">
+            <a:avLst>
+              <a:gd name="adj" fmla="val 50000"/>
+            </a:avLst>
+          </a:prstGeom>
+          <a:solidFill>
+            <a:srgbClr val="030712"/>
+          </a:solidFill>
+          <a:ln w="8903">
+            <a:solidFill>
+              <a:srgbClr val="3B82F6">
+                <a:alpha val="55000"/>
+              </a:srgbClr>
+            </a:solidFill>
+            <a:prstDash val="solid"/>
+          </a:ln>
+        </p:spPr>
+      </p:sp>
+      <p:sp>
+        <p:nvSpPr>
+          <p:cNvPr id="29" name="Schema"/>
+          <p:cNvSpPr/>
+          <p:nvPr/>
+        </p:nvSpPr>
+        <p:spPr>
+          <a:xfrm>
+            <a:off x="9550355" y="4779424"/>
+            <a:ext cx="760960" cy="231488"/>
+          </a:xfrm>
+          <a:prstGeom prst="roundRect">
+            <a:avLst>
+              <a:gd name="adj" fmla="val 50000"/>
+            </a:avLst>
+          </a:prstGeom>
+          <a:solidFill>
+            <a:srgbClr val="030712"/>
+          </a:solidFill>
+          <a:ln w="8903">
+            <a:solidFill>
+              <a:srgbClr val="3B82F6">
+                <a:alpha val="55000"/>
+              </a:srgbClr>
+            </a:solidFill>
+            <a:prstDash val="solid"/>
+          </a:ln>
+        </p:spPr>
+      </p:sp>
+      <p:sp>
+        <p:nvSpPr>
+          <p:cNvPr id="30" name="Text:schema"/>
+          <p:cNvSpPr/>
+          <p:nvPr/>
+        </p:nvSpPr>
+        <p:spPr>
+          <a:xfrm>
+            <a:off x="1377062" y="2375515"/>
+            <a:ext cx="320521" cy="231488"/>
           </a:xfrm>
           <a:prstGeom prst="rect">
             <a:avLst/>
@@ -1873,12 +2071,12 @@
           <a:p>
             <a:pPr marL="0" indent="0" algn="ctr">
               <a:lnSpc>
-                <a:spcPts val="2019"/>
+                <a:spcPts val="1683"/>
               </a:lnSpc>
               <a:buNone/>
             </a:pPr>
             <a:r>
-              <a:rPr lang="en-US" sz="1683" b="1" dirty="0">
+              <a:rPr lang="en-US" sz="1402" b="1" dirty="0">
                 <a:solidFill>
                   <a:srgbClr val="FFFFFF"/>
                 </a:solidFill>
@@ -1888,20 +2086,20 @@
               </a:rPr>
               <a:t>Ctrl</a:t>
             </a:r>
-            <a:endParaRPr lang="en-US" sz="1683" dirty="0"/>
-          </a:p>
-        </p:txBody>
-      </p:sp>
-      <p:sp>
-        <p:nvSpPr>
-          <p:cNvPr id="25" name="Text:schema"/>
-          <p:cNvSpPr/>
-          <p:nvPr/>
-        </p:nvSpPr>
-        <p:spPr>
-          <a:xfrm>
-            <a:off x="2451866" y="2406677"/>
-            <a:ext cx="485790" cy="276004"/>
+            <a:endParaRPr lang="en-US" sz="1402" dirty="0"/>
+          </a:p>
+        </p:txBody>
+      </p:sp>
+      <p:sp>
+        <p:nvSpPr>
+          <p:cNvPr id="31" name="Text:schema"/>
+          <p:cNvSpPr/>
+          <p:nvPr/>
+        </p:nvSpPr>
+        <p:spPr>
+          <a:xfrm>
+            <a:off x="2109504" y="2375515"/>
+            <a:ext cx="404825" cy="231488"/>
           </a:xfrm>
           <a:prstGeom prst="rect">
             <a:avLst/>
@@ -1915,12 +2113,12 @@
           <a:p>
             <a:pPr marL="0" indent="0" algn="ctr">
               <a:lnSpc>
-                <a:spcPts val="2019"/>
+                <a:spcPts val="1683"/>
               </a:lnSpc>
               <a:buNone/>
             </a:pPr>
             <a:r>
-              <a:rPr lang="en-US" sz="1683" b="1" dirty="0">
+              <a:rPr lang="en-US" sz="1402" b="1" dirty="0">
                 <a:solidFill>
                   <a:srgbClr val="FFFFFF"/>
                 </a:solidFill>
@@ -1930,20 +2128,20 @@
               </a:rPr>
               <a:t>Shift</a:t>
             </a:r>
-            <a:endParaRPr lang="en-US" sz="1683" dirty="0"/>
-          </a:p>
-        </p:txBody>
-      </p:sp>
-      <p:sp>
-        <p:nvSpPr>
-          <p:cNvPr id="26" name="Text:schema"/>
-          <p:cNvSpPr/>
-          <p:nvPr/>
-        </p:nvSpPr>
-        <p:spPr>
-          <a:xfrm>
-            <a:off x="3556718" y="2406677"/>
-            <a:ext cx="92233" cy="276004"/>
+            <a:endParaRPr lang="en-US" sz="1402" dirty="0"/>
+          </a:p>
+        </p:txBody>
+      </p:sp>
+      <p:sp>
+        <p:nvSpPr>
+          <p:cNvPr id="32" name="Text:schema"/>
+          <p:cNvSpPr/>
+          <p:nvPr/>
+        </p:nvSpPr>
+        <p:spPr>
+          <a:xfrm>
+            <a:off x="2959080" y="2375515"/>
+            <a:ext cx="76792" cy="231488"/>
           </a:xfrm>
           <a:prstGeom prst="rect">
             <a:avLst/>
@@ -1957,12 +2155,12 @@
           <a:p>
             <a:pPr marL="0" indent="0" algn="ctr">
               <a:lnSpc>
-                <a:spcPts val="2019"/>
+                <a:spcPts val="1683"/>
               </a:lnSpc>
               <a:buNone/>
             </a:pPr>
             <a:r>
-              <a:rPr lang="en-US" sz="1683" b="1" dirty="0">
+              <a:rPr lang="en-US" sz="1402" b="1" dirty="0">
                 <a:solidFill>
                   <a:srgbClr val="FFFFFF"/>
                 </a:solidFill>
@@ -1972,19 +2170,19 @@
               </a:rPr>
               <a:t>1</a:t>
             </a:r>
-            <a:endParaRPr lang="en-US" sz="1683" dirty="0"/>
-          </a:p>
-        </p:txBody>
-      </p:sp>
-      <p:sp>
-        <p:nvSpPr>
-          <p:cNvPr id="27" name="Text:schema"/>
-          <p:cNvSpPr/>
-          <p:nvPr/>
-        </p:nvSpPr>
-        <p:spPr>
-          <a:xfrm>
-            <a:off x="1252415" y="3105591"/>
+            <a:endParaRPr lang="en-US" sz="1402" dirty="0"/>
+          </a:p>
+        </p:txBody>
+      </p:sp>
+      <p:sp>
+        <p:nvSpPr>
+          <p:cNvPr id="33" name="Text:schema"/>
+          <p:cNvSpPr/>
+          <p:nvPr/>
+        </p:nvSpPr>
+        <p:spPr>
+          <a:xfrm>
+            <a:off x="1216802" y="2998751"/>
             <a:ext cx="1326741" cy="160261"/>
           </a:xfrm>
           <a:prstGeom prst="rect">
@@ -2020,14 +2218,14 @@
       </p:sp>
       <p:sp>
         <p:nvSpPr>
-          <p:cNvPr id="28" name="Text:schema"/>
-          <p:cNvSpPr/>
-          <p:nvPr/>
-        </p:nvSpPr>
-        <p:spPr>
-          <a:xfrm>
-            <a:off x="1252415" y="3354885"/>
-            <a:ext cx="1394073" cy="293811"/>
+          <p:cNvPr id="34" name="Text:schema"/>
+          <p:cNvSpPr/>
+          <p:nvPr/>
+        </p:nvSpPr>
+        <p:spPr>
+          <a:xfrm>
+            <a:off x="1216802" y="3248045"/>
+            <a:ext cx="1179557" cy="249294"/>
           </a:xfrm>
           <a:prstGeom prst="rect">
             <a:avLst/>
@@ -2041,12 +2239,12 @@
           <a:p>
             <a:pPr marL="0" indent="0" algn="l">
               <a:lnSpc>
-                <a:spcPts val="2187"/>
+                <a:spcPts val="1851"/>
               </a:lnSpc>
               <a:buNone/>
             </a:pPr>
             <a:r>
-              <a:rPr lang="en-US" sz="1823" b="1" dirty="0">
+              <a:rPr lang="en-US" sz="1542" b="1" dirty="0">
                 <a:solidFill>
                   <a:srgbClr val="FFFFFF"/>
                 </a:solidFill>
@@ -2056,20 +2254,20 @@
               </a:rPr>
               <a:t>Pick a frame</a:t>
             </a:r>
-            <a:endParaRPr lang="en-US" sz="1823" dirty="0"/>
-          </a:p>
-        </p:txBody>
-      </p:sp>
-      <p:sp>
-        <p:nvSpPr>
-          <p:cNvPr id="29" name="Text:schema"/>
-          <p:cNvSpPr/>
-          <p:nvPr/>
-        </p:nvSpPr>
-        <p:spPr>
-          <a:xfrm>
-            <a:off x="1252415" y="3817861"/>
-            <a:ext cx="2971232" cy="441551"/>
+            <a:endParaRPr lang="en-US" sz="1542" dirty="0"/>
+          </a:p>
+        </p:txBody>
+      </p:sp>
+      <p:sp>
+        <p:nvSpPr>
+          <p:cNvPr id="35" name="Text:schema"/>
+          <p:cNvSpPr/>
+          <p:nvPr/>
+        </p:nvSpPr>
+        <p:spPr>
+          <a:xfrm>
+            <a:off x="1216802" y="3675407"/>
+            <a:ext cx="2159601" cy="416511"/>
           </a:xfrm>
           <a:prstGeom prst="rect">
             <a:avLst/>
@@ -2083,12 +2281,12 @@
           <a:p>
             <a:pPr marL="0" indent="0" algn="l">
               <a:lnSpc>
-                <a:spcPts val="1669"/>
+                <a:spcPts val="1570"/>
               </a:lnSpc>
               <a:buNone/>
             </a:pPr>
             <a:r>
-              <a:rPr lang="en-US" sz="1192" dirty="0">
+              <a:rPr lang="en-US" sz="1122" dirty="0">
                 <a:solidFill>
                   <a:srgbClr val="D1D5DB"/>
                 </a:solidFill>
@@ -2098,19 +2296,19 @@
               </a:rPr>
               <a:t>Drag an area, choose one of 10 frames, annotate, hit Enter.</a:t>
             </a:r>
-            <a:endParaRPr lang="en-US" sz="1192" dirty="0"/>
-          </a:p>
-        </p:txBody>
-      </p:sp>
-      <p:sp>
-        <p:nvSpPr>
-          <p:cNvPr id="30" name="Text:schema"/>
-          <p:cNvSpPr/>
-          <p:nvPr/>
-        </p:nvSpPr>
-        <p:spPr>
-          <a:xfrm>
-            <a:off x="1350352" y="4823941"/>
+            <a:endParaRPr lang="en-US" sz="1122" dirty="0"/>
+          </a:p>
+        </p:txBody>
+      </p:sp>
+      <p:sp>
+        <p:nvSpPr>
+          <p:cNvPr id="36" name="Text:schema"/>
+          <p:cNvSpPr/>
+          <p:nvPr/>
+        </p:nvSpPr>
+        <p:spPr>
+          <a:xfrm>
+            <a:off x="1314739" y="4823941"/>
             <a:ext cx="362951" cy="160261"/>
           </a:xfrm>
           <a:prstGeom prst="rect">
@@ -2146,13 +2344,13 @@
       </p:sp>
       <p:sp>
         <p:nvSpPr>
-          <p:cNvPr id="31" name="Text:schema"/>
-          <p:cNvSpPr/>
-          <p:nvPr/>
-        </p:nvSpPr>
-        <p:spPr>
-          <a:xfrm>
-            <a:off x="1971501" y="4823941"/>
+          <p:cNvPr id="37" name="Text:schema"/>
+          <p:cNvSpPr/>
+          <p:nvPr/>
+        </p:nvSpPr>
+        <p:spPr>
+          <a:xfrm>
+            <a:off x="1935888" y="4823941"/>
             <a:ext cx="532115" cy="160261"/>
           </a:xfrm>
           <a:prstGeom prst="rect">
@@ -2188,14 +2386,14 @@
       </p:sp>
       <p:sp>
         <p:nvSpPr>
-          <p:cNvPr id="32" name="Text:schema"/>
-          <p:cNvSpPr/>
-          <p:nvPr/>
-        </p:nvSpPr>
-        <p:spPr>
-          <a:xfrm>
-            <a:off x="4941888" y="2406677"/>
-            <a:ext cx="384653" cy="276004"/>
+          <p:cNvPr id="38" name="Text:schema"/>
+          <p:cNvSpPr/>
+          <p:nvPr/>
+        </p:nvSpPr>
+        <p:spPr>
+          <a:xfrm>
+            <a:off x="3959039" y="2375515"/>
+            <a:ext cx="320521" cy="231488"/>
           </a:xfrm>
           <a:prstGeom prst="rect">
             <a:avLst/>
@@ -2209,12 +2407,12 @@
           <a:p>
             <a:pPr marL="0" indent="0" algn="ctr">
               <a:lnSpc>
-                <a:spcPts val="2019"/>
+                <a:spcPts val="1683"/>
               </a:lnSpc>
               <a:buNone/>
             </a:pPr>
             <a:r>
-              <a:rPr lang="en-US" sz="1683" b="1" dirty="0">
+              <a:rPr lang="en-US" sz="1402" b="1" dirty="0">
                 <a:solidFill>
                   <a:srgbClr val="FFFFFF"/>
                 </a:solidFill>
@@ -2224,20 +2422,20 @@
               </a:rPr>
               <a:t>Ctrl</a:t>
             </a:r>
-            <a:endParaRPr lang="en-US" sz="1683" dirty="0"/>
-          </a:p>
-        </p:txBody>
-      </p:sp>
-      <p:sp>
-        <p:nvSpPr>
-          <p:cNvPr id="33" name="Text:schema"/>
-          <p:cNvSpPr/>
-          <p:nvPr/>
-        </p:nvSpPr>
-        <p:spPr>
-          <a:xfrm>
-            <a:off x="5906373" y="2406677"/>
-            <a:ext cx="485790" cy="276004"/>
+            <a:endParaRPr lang="en-US" sz="1402" dirty="0"/>
+          </a:p>
+        </p:txBody>
+      </p:sp>
+      <p:sp>
+        <p:nvSpPr>
+          <p:cNvPr id="39" name="Text:schema"/>
+          <p:cNvSpPr/>
+          <p:nvPr/>
+        </p:nvSpPr>
+        <p:spPr>
+          <a:xfrm>
+            <a:off x="4691480" y="2375515"/>
+            <a:ext cx="404825" cy="231488"/>
           </a:xfrm>
           <a:prstGeom prst="rect">
             <a:avLst/>
@@ -2251,12 +2449,12 @@
           <a:p>
             <a:pPr marL="0" indent="0" algn="ctr">
               <a:lnSpc>
-                <a:spcPts val="2019"/>
+                <a:spcPts val="1683"/>
               </a:lnSpc>
               <a:buNone/>
             </a:pPr>
             <a:r>
-              <a:rPr lang="en-US" sz="1683" b="1" dirty="0">
+              <a:rPr lang="en-US" sz="1402" b="1" dirty="0">
                 <a:solidFill>
                   <a:srgbClr val="FFFFFF"/>
                 </a:solidFill>
@@ -2266,20 +2464,20 @@
               </a:rPr>
               <a:t>Shift</a:t>
             </a:r>
-            <a:endParaRPr lang="en-US" sz="1683" dirty="0"/>
-          </a:p>
-        </p:txBody>
-      </p:sp>
-      <p:sp>
-        <p:nvSpPr>
-          <p:cNvPr id="34" name="Text:schema"/>
-          <p:cNvSpPr/>
-          <p:nvPr/>
-        </p:nvSpPr>
-        <p:spPr>
-          <a:xfrm>
-            <a:off x="6990080" y="2406677"/>
-            <a:ext cx="134663" cy="276004"/>
+            <a:endParaRPr lang="en-US" sz="1402" dirty="0"/>
+          </a:p>
+        </p:txBody>
+      </p:sp>
+      <p:sp>
+        <p:nvSpPr>
+          <p:cNvPr id="40" name="Text:schema"/>
+          <p:cNvSpPr/>
+          <p:nvPr/>
+        </p:nvSpPr>
+        <p:spPr>
+          <a:xfrm>
+            <a:off x="5523250" y="2375515"/>
+            <a:ext cx="112266" cy="231488"/>
           </a:xfrm>
           <a:prstGeom prst="rect">
             <a:avLst/>
@@ -2293,12 +2491,12 @@
           <a:p>
             <a:pPr marL="0" indent="0" algn="ctr">
               <a:lnSpc>
-                <a:spcPts val="2019"/>
+                <a:spcPts val="1683"/>
               </a:lnSpc>
               <a:buNone/>
             </a:pPr>
             <a:r>
-              <a:rPr lang="en-US" sz="1683" b="1" dirty="0">
+              <a:rPr lang="en-US" sz="1402" b="1" dirty="0">
                 <a:solidFill>
                   <a:srgbClr val="FFFFFF"/>
                 </a:solidFill>
@@ -2308,19 +2506,19 @@
               </a:rPr>
               <a:t>2</a:t>
             </a:r>
-            <a:endParaRPr lang="en-US" sz="1683" dirty="0"/>
-          </a:p>
-        </p:txBody>
-      </p:sp>
-      <p:sp>
-        <p:nvSpPr>
-          <p:cNvPr id="35" name="Text:schema"/>
-          <p:cNvSpPr/>
-          <p:nvPr/>
-        </p:nvSpPr>
-        <p:spPr>
-          <a:xfrm>
-            <a:off x="4706922" y="3105591"/>
+            <a:endParaRPr lang="en-US" sz="1402" dirty="0"/>
+          </a:p>
+        </p:txBody>
+      </p:sp>
+      <p:sp>
+        <p:nvSpPr>
+          <p:cNvPr id="41" name="Text:schema"/>
+          <p:cNvSpPr/>
+          <p:nvPr/>
+        </p:nvSpPr>
+        <p:spPr>
+          <a:xfrm>
+            <a:off x="3798779" y="2998751"/>
             <a:ext cx="740927" cy="160261"/>
           </a:xfrm>
           <a:prstGeom prst="rect">
@@ -2356,14 +2554,14 @@
       </p:sp>
       <p:sp>
         <p:nvSpPr>
-          <p:cNvPr id="36" name="Text:schema"/>
-          <p:cNvSpPr/>
-          <p:nvPr/>
-        </p:nvSpPr>
-        <p:spPr>
-          <a:xfrm>
-            <a:off x="4706922" y="3354885"/>
-            <a:ext cx="1344826" cy="293811"/>
+          <p:cNvPr id="42" name="Text:schema"/>
+          <p:cNvSpPr/>
+          <p:nvPr/>
+        </p:nvSpPr>
+        <p:spPr>
+          <a:xfrm>
+            <a:off x="3798779" y="3248045"/>
+            <a:ext cx="1137962" cy="249294"/>
           </a:xfrm>
           <a:prstGeom prst="rect">
             <a:avLst/>
@@ -2377,12 +2575,12 @@
           <a:p>
             <a:pPr marL="0" indent="0" algn="l">
               <a:lnSpc>
-                <a:spcPts val="2187"/>
+                <a:spcPts val="1851"/>
               </a:lnSpc>
               <a:buNone/>
             </a:pPr>
             <a:r>
-              <a:rPr lang="en-US" sz="1823" b="1" dirty="0">
+              <a:rPr lang="en-US" sz="1542" b="1" dirty="0">
                 <a:solidFill>
                   <a:srgbClr val="FFFFFF"/>
                 </a:solidFill>
@@ -2392,20 +2590,20 @@
               </a:rPr>
               <a:t>Grey border</a:t>
             </a:r>
-            <a:endParaRPr lang="en-US" sz="1823" dirty="0"/>
-          </a:p>
-        </p:txBody>
-      </p:sp>
-      <p:sp>
-        <p:nvSpPr>
-          <p:cNvPr id="37" name="Text:schema"/>
-          <p:cNvSpPr/>
-          <p:nvPr/>
-        </p:nvSpPr>
-        <p:spPr>
-          <a:xfrm>
-            <a:off x="4706922" y="3817861"/>
-            <a:ext cx="2971232" cy="441551"/>
+            <a:endParaRPr lang="en-US" sz="1542" dirty="0"/>
+          </a:p>
+        </p:txBody>
+      </p:sp>
+      <p:sp>
+        <p:nvSpPr>
+          <p:cNvPr id="43" name="Text:schema"/>
+          <p:cNvSpPr/>
+          <p:nvPr/>
+        </p:nvSpPr>
+        <p:spPr>
+          <a:xfrm>
+            <a:off x="3798779" y="3675407"/>
+            <a:ext cx="2159601" cy="615863"/>
           </a:xfrm>
           <a:prstGeom prst="rect">
             <a:avLst/>
@@ -2419,12 +2617,12 @@
           <a:p>
             <a:pPr marL="0" indent="0" algn="l">
               <a:lnSpc>
-                <a:spcPts val="1669"/>
+                <a:spcPts val="1570"/>
               </a:lnSpc>
               <a:buNone/>
             </a:pPr>
             <a:r>
-              <a:rPr lang="en-US" sz="1192" dirty="0">
+              <a:rPr lang="en-US" sz="1122" dirty="0">
                 <a:solidFill>
                   <a:srgbClr val="D1D5DB"/>
                 </a:solidFill>
@@ -2432,22 +2630,22 @@
                 <a:ea typeface="Inter" pitchFamily="34" charset="-122"/>
                 <a:cs typeface="Inter" pitchFamily="34" charset="-120"/>
               </a:rPr>
-              <a:t>Drag an area and you get the rounded grey border. Add an arrow, hit Enter.</a:t>
-            </a:r>
-            <a:endParaRPr lang="en-US" sz="1192" dirty="0"/>
-          </a:p>
-        </p:txBody>
-      </p:sp>
-      <p:sp>
-        <p:nvSpPr>
-          <p:cNvPr id="38" name="Text:schema"/>
-          <p:cNvSpPr/>
-          <p:nvPr/>
-        </p:nvSpPr>
-        <p:spPr>
-          <a:xfrm>
-            <a:off x="4804859" y="4823941"/>
-            <a:ext cx="692098" cy="160261"/>
+              <a:t>Drag an area, get the rounded grey border. Add an arrow, hit Enter.</a:t>
+            </a:r>
+            <a:endParaRPr lang="en-US" sz="1122" dirty="0"/>
+          </a:p>
+        </p:txBody>
+      </p:sp>
+      <p:sp>
+        <p:nvSpPr>
+          <p:cNvPr id="44" name="Text:schema"/>
+          <p:cNvSpPr/>
+          <p:nvPr/>
+        </p:nvSpPr>
+        <p:spPr>
+          <a:xfrm>
+            <a:off x="3896716" y="4823941"/>
+            <a:ext cx="391331" cy="160261"/>
           </a:xfrm>
           <a:prstGeom prst="rect">
             <a:avLst/>
@@ -2474,7 +2672,7 @@
                 <a:ea typeface="Inter" pitchFamily="34" charset="-122"/>
                 <a:cs typeface="Inter" pitchFamily="34" charset="-120"/>
               </a:rPr>
-              <a:t>Grey border</a:t>
+              <a:t>Border</a:t>
             </a:r>
             <a:endParaRPr lang="en-US" sz="946" dirty="0"/>
           </a:p>
@@ -2482,13 +2680,13 @@
       </p:sp>
       <p:sp>
         <p:nvSpPr>
-          <p:cNvPr id="39" name="Text:schema"/>
-          <p:cNvSpPr/>
-          <p:nvPr/>
-        </p:nvSpPr>
-        <p:spPr>
-          <a:xfrm>
-            <a:off x="5755155" y="4823941"/>
+          <p:cNvPr id="45" name="Text:schema"/>
+          <p:cNvSpPr/>
+          <p:nvPr/>
+        </p:nvSpPr>
+        <p:spPr>
+          <a:xfrm>
+            <a:off x="4546244" y="4823941"/>
             <a:ext cx="532115" cy="160261"/>
           </a:xfrm>
           <a:prstGeom prst="rect">
@@ -2524,14 +2722,14 @@
       </p:sp>
       <p:sp>
         <p:nvSpPr>
-          <p:cNvPr id="40" name="Text:schema"/>
-          <p:cNvSpPr/>
-          <p:nvPr/>
-        </p:nvSpPr>
-        <p:spPr>
-          <a:xfrm>
-            <a:off x="8396395" y="2406677"/>
-            <a:ext cx="384653" cy="276004"/>
+          <p:cNvPr id="46" name="Text:schema"/>
+          <p:cNvSpPr/>
+          <p:nvPr/>
+        </p:nvSpPr>
+        <p:spPr>
+          <a:xfrm>
+            <a:off x="6541016" y="2375515"/>
+            <a:ext cx="320521" cy="231488"/>
           </a:xfrm>
           <a:prstGeom prst="rect">
             <a:avLst/>
@@ -2545,12 +2743,12 @@
           <a:p>
             <a:pPr marL="0" indent="0" algn="ctr">
               <a:lnSpc>
-                <a:spcPts val="2019"/>
+                <a:spcPts val="1683"/>
               </a:lnSpc>
               <a:buNone/>
             </a:pPr>
             <a:r>
-              <a:rPr lang="en-US" sz="1683" b="1" dirty="0">
+              <a:rPr lang="en-US" sz="1402" b="1" dirty="0">
                 <a:solidFill>
                   <a:srgbClr val="FFFFFF"/>
                 </a:solidFill>
@@ -2560,20 +2758,20 @@
               </a:rPr>
               <a:t>Ctrl</a:t>
             </a:r>
-            <a:endParaRPr lang="en-US" sz="1683" dirty="0"/>
-          </a:p>
-        </p:txBody>
-      </p:sp>
-      <p:sp>
-        <p:nvSpPr>
-          <p:cNvPr id="41" name="Text:schema"/>
-          <p:cNvSpPr/>
-          <p:nvPr/>
-        </p:nvSpPr>
-        <p:spPr>
-          <a:xfrm>
-            <a:off x="9360880" y="2406677"/>
-            <a:ext cx="485790" cy="276004"/>
+            <a:endParaRPr lang="en-US" sz="1402" dirty="0"/>
+          </a:p>
+        </p:txBody>
+      </p:sp>
+      <p:sp>
+        <p:nvSpPr>
+          <p:cNvPr id="47" name="Text:schema"/>
+          <p:cNvSpPr/>
+          <p:nvPr/>
+        </p:nvSpPr>
+        <p:spPr>
+          <a:xfrm>
+            <a:off x="7273457" y="2375515"/>
+            <a:ext cx="404825" cy="231488"/>
           </a:xfrm>
           <a:prstGeom prst="rect">
             <a:avLst/>
@@ -2587,12 +2785,12 @@
           <a:p>
             <a:pPr marL="0" indent="0" algn="ctr">
               <a:lnSpc>
-                <a:spcPts val="2019"/>
+                <a:spcPts val="1683"/>
               </a:lnSpc>
               <a:buNone/>
             </a:pPr>
             <a:r>
-              <a:rPr lang="en-US" sz="1683" b="1" dirty="0">
+              <a:rPr lang="en-US" sz="1402" b="1" dirty="0">
                 <a:solidFill>
                   <a:srgbClr val="FFFFFF"/>
                 </a:solidFill>
@@ -2602,20 +2800,20 @@
               </a:rPr>
               <a:t>Shift</a:t>
             </a:r>
-            <a:endParaRPr lang="en-US" sz="1683" dirty="0"/>
-          </a:p>
-        </p:txBody>
-      </p:sp>
-      <p:sp>
-        <p:nvSpPr>
-          <p:cNvPr id="42" name="Text:schema"/>
-          <p:cNvSpPr/>
-          <p:nvPr/>
-        </p:nvSpPr>
-        <p:spPr>
-          <a:xfrm>
-            <a:off x="10442917" y="2406677"/>
-            <a:ext cx="138002" cy="276004"/>
+            <a:endParaRPr lang="en-US" sz="1402" dirty="0"/>
+          </a:p>
+        </p:txBody>
+      </p:sp>
+      <p:sp>
+        <p:nvSpPr>
+          <p:cNvPr id="48" name="Text:schema"/>
+          <p:cNvSpPr/>
+          <p:nvPr/>
+        </p:nvSpPr>
+        <p:spPr>
+          <a:xfrm>
+            <a:off x="8103835" y="2375515"/>
+            <a:ext cx="115048" cy="231488"/>
           </a:xfrm>
           <a:prstGeom prst="rect">
             <a:avLst/>
@@ -2629,12 +2827,12 @@
           <a:p>
             <a:pPr marL="0" indent="0" algn="ctr">
               <a:lnSpc>
-                <a:spcPts val="2019"/>
+                <a:spcPts val="1683"/>
               </a:lnSpc>
               <a:buNone/>
             </a:pPr>
             <a:r>
-              <a:rPr lang="en-US" sz="1683" b="1" dirty="0">
+              <a:rPr lang="en-US" sz="1402" b="1" dirty="0">
                 <a:solidFill>
                   <a:srgbClr val="FFFFFF"/>
                 </a:solidFill>
@@ -2644,19 +2842,19 @@
               </a:rPr>
               <a:t>3</a:t>
             </a:r>
-            <a:endParaRPr lang="en-US" sz="1683" dirty="0"/>
-          </a:p>
-        </p:txBody>
-      </p:sp>
-      <p:sp>
-        <p:nvSpPr>
-          <p:cNvPr id="43" name="Text:schema"/>
-          <p:cNvSpPr/>
-          <p:nvPr/>
-        </p:nvSpPr>
-        <p:spPr>
-          <a:xfrm>
-            <a:off x="8161429" y="3105591"/>
+            <a:endParaRPr lang="en-US" sz="1402" dirty="0"/>
+          </a:p>
+        </p:txBody>
+      </p:sp>
+      <p:sp>
+        <p:nvSpPr>
+          <p:cNvPr id="49" name="Text:schema"/>
+          <p:cNvSpPr/>
+          <p:nvPr/>
+        </p:nvSpPr>
+        <p:spPr>
+          <a:xfrm>
+            <a:off x="6380755" y="2998751"/>
             <a:ext cx="626018" cy="160261"/>
           </a:xfrm>
           <a:prstGeom prst="rect">
@@ -2692,14 +2890,14 @@
       </p:sp>
       <p:sp>
         <p:nvSpPr>
-          <p:cNvPr id="44" name="Text:schema"/>
-          <p:cNvSpPr/>
-          <p:nvPr/>
-        </p:nvSpPr>
-        <p:spPr>
-          <a:xfrm>
-            <a:off x="8161429" y="3354885"/>
-            <a:ext cx="2300547" cy="293811"/>
+          <p:cNvPr id="50" name="Text:schema"/>
+          <p:cNvSpPr/>
+          <p:nvPr/>
+        </p:nvSpPr>
+        <p:spPr>
+          <a:xfrm>
+            <a:off x="6380755" y="3248045"/>
+            <a:ext cx="1184565" cy="249294"/>
           </a:xfrm>
           <a:prstGeom prst="rect">
             <a:avLst/>
@@ -2713,12 +2911,12 @@
           <a:p>
             <a:pPr marL="0" indent="0" algn="l">
               <a:lnSpc>
-                <a:spcPts val="2187"/>
+                <a:spcPts val="1851"/>
               </a:lnSpc>
               <a:buNone/>
             </a:pPr>
             <a:r>
-              <a:rPr lang="en-US" sz="1823" b="1" dirty="0">
+              <a:rPr lang="en-US" sz="1542" b="1" dirty="0">
                 <a:solidFill>
                   <a:srgbClr val="FFFFFF"/>
                 </a:solidFill>
@@ -2726,22 +2924,22 @@
                 <a:ea typeface="Inter" pitchFamily="34" charset="-122"/>
                 <a:cs typeface="Inter" pitchFamily="34" charset="-120"/>
               </a:rPr>
-              <a:t>Straight to clipboard</a:t>
-            </a:r>
-            <a:endParaRPr lang="en-US" sz="1823" dirty="0"/>
-          </a:p>
-        </p:txBody>
-      </p:sp>
-      <p:sp>
-        <p:nvSpPr>
-          <p:cNvPr id="45" name="Text:schema"/>
-          <p:cNvSpPr/>
-          <p:nvPr/>
-        </p:nvSpPr>
-        <p:spPr>
-          <a:xfrm>
-            <a:off x="8161429" y="3817861"/>
-            <a:ext cx="2971232" cy="441551"/>
+              <a:t>To clipboard</a:t>
+            </a:r>
+            <a:endParaRPr lang="en-US" sz="1542" dirty="0"/>
+          </a:p>
+        </p:txBody>
+      </p:sp>
+      <p:sp>
+        <p:nvSpPr>
+          <p:cNvPr id="51" name="Text:schema"/>
+          <p:cNvSpPr/>
+          <p:nvPr/>
+        </p:nvSpPr>
+        <p:spPr>
+          <a:xfrm>
+            <a:off x="6380755" y="3675407"/>
+            <a:ext cx="2159601" cy="615863"/>
           </a:xfrm>
           <a:prstGeom prst="rect">
             <a:avLst/>
@@ -2755,12 +2953,12 @@
           <a:p>
             <a:pPr marL="0" indent="0" algn="l">
               <a:lnSpc>
-                <a:spcPts val="1669"/>
+                <a:spcPts val="1570"/>
               </a:lnSpc>
               <a:buNone/>
             </a:pPr>
             <a:r>
-              <a:rPr lang="en-US" sz="1192" dirty="0">
+              <a:rPr lang="en-US" sz="1122" dirty="0">
                 <a:solidFill>
                   <a:srgbClr val="D1D5DB"/>
                 </a:solidFill>
@@ -2770,20 +2968,20 @@
               </a:rPr>
               <a:t>No editor. Paste it into an AI chat, Teams or a mail right away.</a:t>
             </a:r>
-            <a:endParaRPr lang="en-US" sz="1192" dirty="0"/>
-          </a:p>
-        </p:txBody>
-      </p:sp>
-      <p:sp>
-        <p:nvSpPr>
-          <p:cNvPr id="46" name="Text:schema"/>
-          <p:cNvSpPr/>
-          <p:nvPr/>
-        </p:nvSpPr>
-        <p:spPr>
-          <a:xfrm>
-            <a:off x="8259366" y="4823941"/>
-            <a:ext cx="692098" cy="160261"/>
+            <a:endParaRPr lang="en-US" sz="1122" dirty="0"/>
+          </a:p>
+        </p:txBody>
+      </p:sp>
+      <p:sp>
+        <p:nvSpPr>
+          <p:cNvPr id="52" name="Text:schema"/>
+          <p:cNvSpPr/>
+          <p:nvPr/>
+        </p:nvSpPr>
+        <p:spPr>
+          <a:xfrm>
+            <a:off x="6478692" y="4823941"/>
+            <a:ext cx="391331" cy="160261"/>
           </a:xfrm>
           <a:prstGeom prst="rect">
             <a:avLst/>
@@ -2810,7 +3008,7 @@
                 <a:ea typeface="Inter" pitchFamily="34" charset="-122"/>
                 <a:cs typeface="Inter" pitchFamily="34" charset="-120"/>
               </a:rPr>
-              <a:t>Grey border</a:t>
+              <a:t>Border</a:t>
             </a:r>
             <a:endParaRPr lang="en-US" sz="946" dirty="0"/>
           </a:p>
@@ -2818,13 +3016,13 @@
       </p:sp>
       <p:sp>
         <p:nvSpPr>
-          <p:cNvPr id="47" name="Text:schema"/>
-          <p:cNvSpPr/>
-          <p:nvPr/>
-        </p:nvSpPr>
-        <p:spPr>
-          <a:xfrm>
-            <a:off x="9209662" y="4823941"/>
+          <p:cNvPr id="53" name="Text:schema"/>
+          <p:cNvSpPr/>
+          <p:nvPr/>
+        </p:nvSpPr>
+        <p:spPr>
+          <a:xfrm>
+            <a:off x="7128221" y="4823941"/>
             <a:ext cx="565086" cy="160261"/>
           </a:xfrm>
           <a:prstGeom prst="rect">
@@ -2860,7 +3058,343 @@
       </p:sp>
       <p:sp>
         <p:nvSpPr>
-          <p:cNvPr id="48" name="Gradient"/>
+          <p:cNvPr id="54" name="Text:schema"/>
+          <p:cNvSpPr/>
+          <p:nvPr/>
+        </p:nvSpPr>
+        <p:spPr>
+          <a:xfrm>
+            <a:off x="9122993" y="2375515"/>
+            <a:ext cx="320521" cy="231488"/>
+          </a:xfrm>
+          <a:prstGeom prst="rect">
+            <a:avLst/>
+          </a:prstGeom>
+          <a:noFill/>
+          <a:ln/>
+        </p:spPr>
+        <p:txBody>
+          <a:bodyPr wrap="none" lIns="0" tIns="0" rIns="0" bIns="0" rtlCol="0" anchor="t"/>
+          <a:lstStyle/>
+          <a:p>
+            <a:pPr marL="0" indent="0" algn="ctr">
+              <a:lnSpc>
+                <a:spcPts val="1683"/>
+              </a:lnSpc>
+              <a:buNone/>
+            </a:pPr>
+            <a:r>
+              <a:rPr lang="en-US" sz="1402" b="1" dirty="0">
+                <a:solidFill>
+                  <a:srgbClr val="FFFFFF"/>
+                </a:solidFill>
+                <a:latin typeface="Inter" pitchFamily="34" charset="0"/>
+                <a:ea typeface="Inter" pitchFamily="34" charset="-122"/>
+                <a:cs typeface="Inter" pitchFamily="34" charset="-120"/>
+              </a:rPr>
+              <a:t>Ctrl</a:t>
+            </a:r>
+            <a:endParaRPr lang="en-US" sz="1402" dirty="0"/>
+          </a:p>
+        </p:txBody>
+      </p:sp>
+      <p:sp>
+        <p:nvSpPr>
+          <p:cNvPr id="55" name="Text:schema"/>
+          <p:cNvSpPr/>
+          <p:nvPr/>
+        </p:nvSpPr>
+        <p:spPr>
+          <a:xfrm>
+            <a:off x="9855434" y="2375515"/>
+            <a:ext cx="404825" cy="231488"/>
+          </a:xfrm>
+          <a:prstGeom prst="rect">
+            <a:avLst/>
+          </a:prstGeom>
+          <a:noFill/>
+          <a:ln/>
+        </p:spPr>
+        <p:txBody>
+          <a:bodyPr wrap="none" lIns="0" tIns="0" rIns="0" bIns="0" rtlCol="0" anchor="t"/>
+          <a:lstStyle/>
+          <a:p>
+            <a:pPr marL="0" indent="0" algn="ctr">
+              <a:lnSpc>
+                <a:spcPts val="1683"/>
+              </a:lnSpc>
+              <a:buNone/>
+            </a:pPr>
+            <a:r>
+              <a:rPr lang="en-US" sz="1402" b="1" dirty="0">
+                <a:solidFill>
+                  <a:srgbClr val="FFFFFF"/>
+                </a:solidFill>
+                <a:latin typeface="Inter" pitchFamily="34" charset="0"/>
+                <a:ea typeface="Inter" pitchFamily="34" charset="-122"/>
+                <a:cs typeface="Inter" pitchFamily="34" charset="-120"/>
+              </a:rPr>
+              <a:t>Shift</a:t>
+            </a:r>
+            <a:endParaRPr lang="en-US" sz="1402" dirty="0"/>
+          </a:p>
+        </p:txBody>
+      </p:sp>
+      <p:sp>
+        <p:nvSpPr>
+          <p:cNvPr id="56" name="Text:schema"/>
+          <p:cNvSpPr/>
+          <p:nvPr/>
+        </p:nvSpPr>
+        <p:spPr>
+          <a:xfrm>
+            <a:off x="10683169" y="2375515"/>
+            <a:ext cx="120474" cy="231488"/>
+          </a:xfrm>
+          <a:prstGeom prst="rect">
+            <a:avLst/>
+          </a:prstGeom>
+          <a:noFill/>
+          <a:ln/>
+        </p:spPr>
+        <p:txBody>
+          <a:bodyPr wrap="none" lIns="0" tIns="0" rIns="0" bIns="0" rtlCol="0" anchor="t"/>
+          <a:lstStyle/>
+          <a:p>
+            <a:pPr marL="0" indent="0" algn="ctr">
+              <a:lnSpc>
+                <a:spcPts val="1683"/>
+              </a:lnSpc>
+              <a:buNone/>
+            </a:pPr>
+            <a:r>
+              <a:rPr lang="en-US" sz="1402" b="1" dirty="0">
+                <a:solidFill>
+                  <a:srgbClr val="FFFFFF"/>
+                </a:solidFill>
+                <a:latin typeface="Inter" pitchFamily="34" charset="0"/>
+                <a:ea typeface="Inter" pitchFamily="34" charset="-122"/>
+                <a:cs typeface="Inter" pitchFamily="34" charset="-120"/>
+              </a:rPr>
+              <a:t>4</a:t>
+            </a:r>
+            <a:endParaRPr lang="en-US" sz="1402" dirty="0"/>
+          </a:p>
+        </p:txBody>
+      </p:sp>
+      <p:sp>
+        <p:nvSpPr>
+          <p:cNvPr id="57" name="Text:schema"/>
+          <p:cNvSpPr/>
+          <p:nvPr/>
+        </p:nvSpPr>
+        <p:spPr>
+          <a:xfrm>
+            <a:off x="8962732" y="2998751"/>
+            <a:ext cx="894093" cy="160261"/>
+          </a:xfrm>
+          <a:prstGeom prst="rect">
+            <a:avLst/>
+          </a:prstGeom>
+          <a:noFill/>
+          <a:ln/>
+        </p:spPr>
+        <p:txBody>
+          <a:bodyPr wrap="none" lIns="0" tIns="0" rIns="0" bIns="0" rtlCol="0" anchor="t"/>
+          <a:lstStyle/>
+          <a:p>
+            <a:pPr marL="0" indent="0" algn="l">
+              <a:lnSpc>
+                <a:spcPts val="1094"/>
+              </a:lnSpc>
+              <a:buNone/>
+            </a:pPr>
+            <a:r>
+              <a:rPr lang="en-US" sz="911" b="1" kern="0" spc="128" dirty="0">
+                <a:solidFill>
+                  <a:srgbClr val="9CA3AF"/>
+                </a:solidFill>
+                <a:latin typeface="Inter" pitchFamily="34" charset="0"/>
+                <a:ea typeface="Inter" pitchFamily="34" charset="-122"/>
+                <a:cs typeface="Inter" pitchFamily="34" charset="-120"/>
+              </a:rPr>
+              <a:t>LONG PAGES</a:t>
+            </a:r>
+            <a:endParaRPr lang="en-US" sz="911" dirty="0"/>
+          </a:p>
+        </p:txBody>
+      </p:sp>
+      <p:sp>
+        <p:nvSpPr>
+          <p:cNvPr id="58" name="Text:schema"/>
+          <p:cNvSpPr/>
+          <p:nvPr/>
+        </p:nvSpPr>
+        <p:spPr>
+          <a:xfrm>
+            <a:off x="8962732" y="3248045"/>
+            <a:ext cx="1629734" cy="249294"/>
+          </a:xfrm>
+          <a:prstGeom prst="rect">
+            <a:avLst/>
+          </a:prstGeom>
+          <a:noFill/>
+          <a:ln/>
+        </p:spPr>
+        <p:txBody>
+          <a:bodyPr wrap="none" lIns="0" tIns="0" rIns="0" bIns="0" rtlCol="0" anchor="t"/>
+          <a:lstStyle/>
+          <a:p>
+            <a:pPr marL="0" indent="0" algn="l">
+              <a:lnSpc>
+                <a:spcPts val="1851"/>
+              </a:lnSpc>
+              <a:buNone/>
+            </a:pPr>
+            <a:r>
+              <a:rPr lang="en-US" sz="1542" b="1" dirty="0">
+                <a:solidFill>
+                  <a:srgbClr val="FFFFFF"/>
+                </a:solidFill>
+                <a:latin typeface="Inter" pitchFamily="34" charset="0"/>
+                <a:ea typeface="Inter" pitchFamily="34" charset="-122"/>
+                <a:cs typeface="Inter" pitchFamily="34" charset="-120"/>
+              </a:rPr>
+              <a:t>Scrolling capture</a:t>
+            </a:r>
+            <a:endParaRPr lang="en-US" sz="1542" dirty="0"/>
+          </a:p>
+        </p:txBody>
+      </p:sp>
+      <p:sp>
+        <p:nvSpPr>
+          <p:cNvPr id="59" name="Text:schema"/>
+          <p:cNvSpPr/>
+          <p:nvPr/>
+        </p:nvSpPr>
+        <p:spPr>
+          <a:xfrm>
+            <a:off x="8962732" y="3675407"/>
+            <a:ext cx="2159601" cy="416511"/>
+          </a:xfrm>
+          <a:prstGeom prst="rect">
+            <a:avLst/>
+          </a:prstGeom>
+          <a:noFill/>
+          <a:ln/>
+        </p:spPr>
+        <p:txBody>
+          <a:bodyPr wrap="square" lIns="0" tIns="0" rIns="0" bIns="0" rtlCol="0" anchor="t"/>
+          <a:lstStyle/>
+          <a:p>
+            <a:pPr marL="0" indent="0" algn="l">
+              <a:lnSpc>
+                <a:spcPts val="1570"/>
+              </a:lnSpc>
+              <a:buNone/>
+            </a:pPr>
+            <a:r>
+              <a:rPr lang="en-US" sz="1122" dirty="0">
+                <a:solidFill>
+                  <a:srgbClr val="D1D5DB"/>
+                </a:solidFill>
+                <a:latin typeface="Inter" pitchFamily="34" charset="0"/>
+                <a:ea typeface="Inter" pitchFamily="34" charset="-122"/>
+                <a:cs typeface="Inter" pitchFamily="34" charset="-120"/>
+              </a:rPr>
+              <a:t>Pick a window and a long page becomes one image.</a:t>
+            </a:r>
+            <a:endParaRPr lang="en-US" sz="1122" dirty="0"/>
+          </a:p>
+        </p:txBody>
+      </p:sp>
+      <p:sp>
+        <p:nvSpPr>
+          <p:cNvPr id="60" name="Text:schema"/>
+          <p:cNvSpPr/>
+          <p:nvPr/>
+        </p:nvSpPr>
+        <p:spPr>
+          <a:xfrm>
+            <a:off x="9060669" y="4823941"/>
+            <a:ext cx="329425" cy="160261"/>
+          </a:xfrm>
+          <a:prstGeom prst="rect">
+            <a:avLst/>
+          </a:prstGeom>
+          <a:noFill/>
+          <a:ln/>
+        </p:spPr>
+        <p:txBody>
+          <a:bodyPr wrap="none" lIns="0" tIns="0" rIns="0" bIns="0" rtlCol="0" anchor="t"/>
+          <a:lstStyle/>
+          <a:p>
+            <a:pPr marL="0" indent="0" algn="l">
+              <a:lnSpc>
+                <a:spcPts val="1136"/>
+              </a:lnSpc>
+              <a:buNone/>
+            </a:pPr>
+            <a:r>
+              <a:rPr lang="en-US" sz="946" b="1" dirty="0">
+                <a:solidFill>
+                  <a:srgbClr val="93C5FD"/>
+                </a:solidFill>
+                <a:latin typeface="Inter" pitchFamily="34" charset="0"/>
+                <a:ea typeface="Inter" pitchFamily="34" charset="-122"/>
+                <a:cs typeface="Inter" pitchFamily="34" charset="-120"/>
+              </a:rPr>
+              <a:t>Scroll</a:t>
+            </a:r>
+            <a:endParaRPr lang="en-US" sz="946" dirty="0"/>
+          </a:p>
+        </p:txBody>
+      </p:sp>
+      <p:sp>
+        <p:nvSpPr>
+          <p:cNvPr id="61" name="Text:schema"/>
+          <p:cNvSpPr/>
+          <p:nvPr/>
+        </p:nvSpPr>
+        <p:spPr>
+          <a:xfrm>
+            <a:off x="9648292" y="4823941"/>
+            <a:ext cx="565086" cy="160261"/>
+          </a:xfrm>
+          <a:prstGeom prst="rect">
+            <a:avLst/>
+          </a:prstGeom>
+          <a:noFill/>
+          <a:ln/>
+        </p:spPr>
+        <p:txBody>
+          <a:bodyPr wrap="none" lIns="0" tIns="0" rIns="0" bIns="0" rtlCol="0" anchor="t"/>
+          <a:lstStyle/>
+          <a:p>
+            <a:pPr marL="0" indent="0" algn="l">
+              <a:lnSpc>
+                <a:spcPts val="1136"/>
+              </a:lnSpc>
+              <a:buNone/>
+            </a:pPr>
+            <a:r>
+              <a:rPr lang="en-US" sz="946" b="1" dirty="0">
+                <a:solidFill>
+                  <a:srgbClr val="93C5FD"/>
+                </a:solidFill>
+                <a:latin typeface="Inter" pitchFamily="34" charset="0"/>
+                <a:ea typeface="Inter" pitchFamily="34" charset="-122"/>
+                <a:cs typeface="Inter" pitchFamily="34" charset="-120"/>
+              </a:rPr>
+              <a:t>Clipboard</a:t>
+            </a:r>
+            <a:endParaRPr lang="en-US" sz="946" dirty="0"/>
+          </a:p>
+        </p:txBody>
+      </p:sp>
+      <p:sp>
+        <p:nvSpPr>
+          <p:cNvPr id="62" name="Gradient"/>
           <p:cNvSpPr/>
           <p:nvPr/>
         </p:nvSpPr>
@@ -2895,7 +3429,7 @@
       </p:sp>
       <p:sp>
         <p:nvSpPr>
-          <p:cNvPr id="49" name="Gradient"/>
+          <p:cNvPr id="63" name="Gradient"/>
           <p:cNvSpPr/>
           <p:nvPr/>
         </p:nvSpPr>
@@ -2923,7 +3457,7 @@
       </p:sp>
       <p:sp>
         <p:nvSpPr>
-          <p:cNvPr id="50" name="Text 47"/>
+          <p:cNvPr id="64" name="Text 61"/>
           <p:cNvSpPr/>
           <p:nvPr/>
         </p:nvSpPr>
@@ -2984,7 +3518,7 @@
       </p:sp>
       <p:sp>
         <p:nvSpPr>
-          <p:cNvPr id="51" name="Slide Number Placeholder 0"/>
+          <p:cNvPr id="65" name="Slide Number Placeholder 0"/>
           <p:cNvSpPr>
             <a:spLocks noGrp="1"/>
           </p:cNvSpPr>

</xml_diff>

<commit_message>
Update training slides with real-use examples per shortcut
Co-authored-by: Copilot App <223556219+Copilot@users.noreply.github.com>
</commit_message>
<xml_diff>
--- a/ShareX mini training.pptx
+++ b/ShareX mini training.pptx
@@ -108,12 +108,12 @@
   <p:extLst>
     <p:ext uri="{521415D9-36F7-43E2-AB2F-B90AF26B5E84}">
       <p14:sectionLst xmlns:p14="http://schemas.microsoft.com/office/powerpoint/2010/main">
-        <p14:section name="Shortcuts" id="{C4E14D8D-622B-1CE6-1D8B-9DFDC4E09D47}">
+        <p14:section name="Shortcuts" id="{5363B8AC-4CC6-0837-78CD-5F6AE58F0DB2}">
           <p14:sldIdLst>
             <p14:sldId id="256"/>
           </p14:sldIdLst>
         </p14:section>
-        <p14:section name="Try it" id="{4F949A32-8E19-D33E-621C-342B941E91D8}">
+        <p14:section name="Try it" id="{80C7E60D-5D05-0397-F67E-7F5088B0A635}">
           <p14:sldIdLst>
             <p14:sldId id="257"/>
           </p14:sldIdLst>
@@ -152,7 +152,7 @@
     </p:spTree>
     <p:extLst>
       <p:ext uri="{BB962C8B-B14F-4D97-AF65-F5344CB8AC3E}">
-        <p14:creationId xmlns:p14="http://schemas.microsoft.com/office/powerpoint/2010/main" val="1436382890"/>
+        <p14:creationId xmlns:p14="http://schemas.microsoft.com/office/powerpoint/2010/main" val="621387995"/>
       </p:ext>
     </p:extLst>
   </p:cSld>
@@ -298,7 +298,7 @@
           <a:p>
             <a:r>
               <a:rPr lang="en-US" dirty="0"/>
-              <a:t>Ctrl+Shift+1: frame chooser. Ctrl+Shift+2: default grey rounded border. Ctrl+Shift+3: straight to the clipboard, ideal for pasting into AI when you want speed. Ctrl+Shift+4: scrolling capture, click the window and ShareX scrolls and stitches one long image.</a:t>
+              <a:t>Ctrl+Shift+1: share something with context or play with the frames. Ctrl+Shift+2: annotate with arrows and text and paste into a mail. Ctrl+Shift+3: spot a bug in Cube and paste it straight into AI. Ctrl+Shift+4: scrolling capture, for example a long DataMiner Assistant chat: click the window and ShareX scrolls and stitches one long image.</a:t>
             </a:r>
           </a:p>
         </p:txBody>
@@ -2183,7 +2183,7 @@
         <p:spPr>
           <a:xfrm>
             <a:off x="1216802" y="2998751"/>
-            <a:ext cx="1326741" cy="160261"/>
+            <a:ext cx="1230195" cy="160261"/>
           </a:xfrm>
           <a:prstGeom prst="rect">
             <a:avLst/>
@@ -2210,7 +2210,7 @@
                 <a:ea typeface="Inter" pitchFamily="34" charset="-122"/>
                 <a:cs typeface="Inter" pitchFamily="34" charset="-120"/>
               </a:rPr>
-              <a:t>WHEN IT MATTERS</a:t>
+              <a:t>SHARE AND PLAY</a:t>
             </a:r>
             <a:endParaRPr lang="en-US" sz="911" dirty="0"/>
           </a:p>
@@ -2267,7 +2267,7 @@
         <p:spPr>
           <a:xfrm>
             <a:off x="1216802" y="3675407"/>
-            <a:ext cx="2159601" cy="416511"/>
+            <a:ext cx="2008600" cy="615863"/>
           </a:xfrm>
           <a:prstGeom prst="rect">
             <a:avLst/>
@@ -2294,7 +2294,7 @@
                 <a:ea typeface="Inter" pitchFamily="34" charset="-122"/>
                 <a:cs typeface="Inter" pitchFamily="34" charset="-120"/>
               </a:rPr>
-              <a:t>Drag an area, choose one of 10 frames, annotate, hit Enter.</a:t>
+              <a:t>Sharing something with some context? Or just have fun with the frames.</a:t>
             </a:r>
             <a:endParaRPr lang="en-US" sz="1122" dirty="0"/>
           </a:p>
@@ -2519,7 +2519,7 @@
         <p:spPr>
           <a:xfrm>
             <a:off x="3798779" y="2998751"/>
-            <a:ext cx="740927" cy="160261"/>
+            <a:ext cx="1117651" cy="160261"/>
           </a:xfrm>
           <a:prstGeom prst="rect">
             <a:avLst/>
@@ -2546,7 +2546,7 @@
                 <a:ea typeface="Inter" pitchFamily="34" charset="-122"/>
                 <a:cs typeface="Inter" pitchFamily="34" charset="-120"/>
               </a:rPr>
-              <a:t>DAILY USE</a:t>
+              <a:t>FOR YOUR MAIL</a:t>
             </a:r>
             <a:endParaRPr lang="en-US" sz="911" dirty="0"/>
           </a:p>
@@ -2561,7 +2561,7 @@
         <p:spPr>
           <a:xfrm>
             <a:off x="3798779" y="3248045"/>
-            <a:ext cx="1137962" cy="249294"/>
+            <a:ext cx="883242" cy="249294"/>
           </a:xfrm>
           <a:prstGeom prst="rect">
             <a:avLst/>
@@ -2588,7 +2588,7 @@
                 <a:ea typeface="Inter" pitchFamily="34" charset="-122"/>
                 <a:cs typeface="Inter" pitchFamily="34" charset="-120"/>
               </a:rPr>
-              <a:t>Grey border</a:t>
+              <a:t>Annotate</a:t>
             </a:r>
             <a:endParaRPr lang="en-US" sz="1542" dirty="0"/>
           </a:p>
@@ -2603,7 +2603,7 @@
         <p:spPr>
           <a:xfrm>
             <a:off x="3798779" y="3675407"/>
-            <a:ext cx="2159601" cy="615863"/>
+            <a:ext cx="2008600" cy="416511"/>
           </a:xfrm>
           <a:prstGeom prst="rect">
             <a:avLst/>
@@ -2630,7 +2630,7 @@
                 <a:ea typeface="Inter" pitchFamily="34" charset="-122"/>
                 <a:cs typeface="Inter" pitchFamily="34" charset="-120"/>
               </a:rPr>
-              <a:t>Drag an area, get the rounded grey border. Add an arrow, hit Enter.</a:t>
+              <a:t>Add arrows and text, then paste it into a mail.</a:t>
             </a:r>
             <a:endParaRPr lang="en-US" sz="1122" dirty="0"/>
           </a:p>
@@ -2855,7 +2855,7 @@
         <p:spPr>
           <a:xfrm>
             <a:off x="6380755" y="2998751"/>
-            <a:ext cx="626018" cy="160261"/>
+            <a:ext cx="1331332" cy="160261"/>
           </a:xfrm>
           <a:prstGeom prst="rect">
             <a:avLst/>
@@ -2882,7 +2882,7 @@
                 <a:ea typeface="Inter" pitchFamily="34" charset="-122"/>
                 <a:cs typeface="Inter" pitchFamily="34" charset="-120"/>
               </a:rPr>
-              <a:t>FASTEST</a:t>
+              <a:t>QUICK BUG CHECK</a:t>
             </a:r>
             <a:endParaRPr lang="en-US" sz="911" dirty="0"/>
           </a:p>
@@ -2897,7 +2897,7 @@
         <p:spPr>
           <a:xfrm>
             <a:off x="6380755" y="3248045"/>
-            <a:ext cx="1184565" cy="249294"/>
+            <a:ext cx="1245359" cy="249294"/>
           </a:xfrm>
           <a:prstGeom prst="rect">
             <a:avLst/>
@@ -2924,7 +2924,7 @@
                 <a:ea typeface="Inter" pitchFamily="34" charset="-122"/>
                 <a:cs typeface="Inter" pitchFamily="34" charset="-120"/>
               </a:rPr>
-              <a:t>To clipboard</a:t>
+              <a:t>Straight to AI</a:t>
             </a:r>
             <a:endParaRPr lang="en-US" sz="1542" dirty="0"/>
           </a:p>
@@ -2939,7 +2939,7 @@
         <p:spPr>
           <a:xfrm>
             <a:off x="6380755" y="3675407"/>
-            <a:ext cx="2159601" cy="615863"/>
+            <a:ext cx="2008600" cy="615863"/>
           </a:xfrm>
           <a:prstGeom prst="rect">
             <a:avLst/>
@@ -2966,7 +2966,7 @@
                 <a:ea typeface="Inter" pitchFamily="34" charset="-122"/>
                 <a:cs typeface="Inter" pitchFamily="34" charset="-120"/>
               </a:rPr>
-              <a:t>No editor. Paste it into an AI chat, Teams or a mail right away.</a:t>
+              <a:t>Odd thing in Cube? One drag, paste it into an AI chat. No editor.</a:t>
             </a:r>
             <a:endParaRPr lang="en-US" sz="1122" dirty="0"/>
           </a:p>
@@ -3191,7 +3191,7 @@
         <p:spPr>
           <a:xfrm>
             <a:off x="8962732" y="2998751"/>
-            <a:ext cx="894093" cy="160261"/>
+            <a:ext cx="913847" cy="160261"/>
           </a:xfrm>
           <a:prstGeom prst="rect">
             <a:avLst/>
@@ -3218,7 +3218,7 @@
                 <a:ea typeface="Inter" pitchFamily="34" charset="-122"/>
                 <a:cs typeface="Inter" pitchFamily="34" charset="-120"/>
               </a:rPr>
-              <a:t>LONG PAGES</a:t>
+              <a:t>LONG CHATS</a:t>
             </a:r>
             <a:endParaRPr lang="en-US" sz="911" dirty="0"/>
           </a:p>
@@ -3275,7 +3275,7 @@
         <p:spPr>
           <a:xfrm>
             <a:off x="8962732" y="3675407"/>
-            <a:ext cx="2159601" cy="416511"/>
+            <a:ext cx="2008600" cy="416511"/>
           </a:xfrm>
           <a:prstGeom prst="rect">
             <a:avLst/>
@@ -3302,7 +3302,7 @@
                 <a:ea typeface="Inter" pitchFamily="34" charset="-122"/>
                 <a:cs typeface="Inter" pitchFamily="34" charset="-120"/>
               </a:rPr>
-              <a:t>Pick a window and a long page becomes one image.</a:t>
+              <a:t>A long DataMiner Assistant chat becomes one image.</a:t>
             </a:r>
             <a:endParaRPr lang="en-US" sz="1122" dirty="0"/>
           </a:p>

</xml_diff>